<commit_message>
Rewrite speaker notes as continuous read-aloud prose
</commit_message>
<xml_diff>
--- a/Final_Presentation_Pipeline_Karimi_Lobo.pptx
+++ b/Final_Presentation_Pipeline_Karimi_Lobo.pptx
@@ -513,7 +513,7 @@
           <a:lstStyle/>
           <a:p>
             <a:r>
-              <a:t>[10s  |  BORNA  |  ~21 words @ 126 wpm]</a:t>
+              <a:t>[10s  |  BORNA  |  ~27 words @ 162 wpm]</a:t>
             </a:r>
           </a:p>
           <a:p>
@@ -524,12 +524,12 @@
           <a:p/>
           <a:p>
             <a:r>
-              <a:t>We measure how late Bay Area transit actually is. The catch: no agency</a:t>
-            </a:r>
-          </a:p>
-          <a:p>
-            <a:r>
-              <a:t>publishes that number. We had to derive it.</a:t>
+              <a:t>We measure how late Bay Area transit actually is. The catch that shaped this</a:t>
+            </a:r>
+          </a:p>
+          <a:p>
+            <a:r>
+              <a:t>whole project is that no agency publishes that number, so we derive it.</a:t>
             </a:r>
           </a:p>
           <a:p/>
@@ -540,7 +540,7 @@
           </a:p>
           <a:p>
             <a:r>
-              <a:t>DELIVERY: Do not linger. The hook is next.</a:t>
+              <a:t>DELIVERY: Don't linger — the hook is the next slide.</a:t>
             </a:r>
           </a:p>
         </p:txBody>
@@ -610,7 +610,7 @@
           <a:lstStyle/>
           <a:p>
             <a:r>
-              <a:t>[36s  |  AATISH  |  ~86 words @ 143 wpm]</a:t>
+              <a:t>[38s  |  AATISH  |  ~108 words @ 171 wpm]</a:t>
             </a:r>
           </a:p>
           <a:p>
@@ -621,50 +621,53 @@
           <a:p/>
           <a:p>
             <a:r>
-              <a:t>Our main limitation is coverage. We catch about twenty-one percent of stop</a:t>
-            </a:r>
-          </a:p>
-          <a:p>
-            <a:r>
-              <a:t>events, because vehicles dwell for seconds and we sample every two minutes.</a:t>
+              <a:t>Our main limitation is coverage, because we catch only about twenty-one</a:t>
+            </a:r>
+          </a:p>
+          <a:p>
+            <a:r>
+              <a:t>percent of stop events. Vehicles dwell at a stop for a matter of seconds while we</a:t>
+            </a:r>
+          </a:p>
+          <a:p>
+            <a:r>
+              <a:t>sample every two minutes. And it is not random either, since the chance of</a:t>
+            </a:r>
+          </a:p>
+          <a:p>
+            <a:r>
+              <a:t>catching a stop scales with how long the vehicle sits there, so terminals and</a:t>
+            </a:r>
+          </a:p>
+          <a:p>
+            <a:r>
+              <a:t>layovers end up over-represented and our derived arrivals skew late. That means</a:t>
+            </a:r>
+          </a:p>
+          <a:p>
+            <a:r>
+              <a:t>the optimism we measured should be read as an upper bound rather than a point</a:t>
+            </a:r>
+          </a:p>
+          <a:p>
+            <a:r>
+              <a:t>estimate. So our next step is deliberately small: one email to 511 requesting a</a:t>
+            </a:r>
+          </a:p>
+          <a:p>
+            <a:r>
+              <a:t>higher rate limit, which attacks all three of those problems at once.</a:t>
             </a:r>
           </a:p>
           <a:p/>
           <a:p>
             <a:r>
-              <a:t>And it is not random -- the chance of catching a stop scales with how long the</a:t>
-            </a:r>
-          </a:p>
-          <a:p>
-            <a:r>
-              <a:t>vehicle sits there, so terminals are over-represented and our arrivals skew late.</a:t>
-            </a:r>
-          </a:p>
-          <a:p>
-            <a:r>
-              <a:t>So the optimism we measured is an upper bound, not a point estimate.</a:t>
-            </a:r>
-          </a:p>
-          <a:p/>
-          <a:p>
-            <a:r>
-              <a:t>The next step is one email: ask 511 for a higher rate limit. That fixes all three</a:t>
-            </a:r>
-          </a:p>
-          <a:p>
-            <a:r>
-              <a:t>problems at once.</a:t>
-            </a:r>
-          </a:p>
-          <a:p/>
-          <a:p>
-            <a:r>
               <a:t>--------------------------------------------------------------</a:t>
             </a:r>
           </a:p>
           <a:p>
             <a:r>
-              <a:t>DELIVERY: Being honest about the upper bound is worth marks. Do not soften it.</a:t>
+              <a:t>DELIVERY: Being honest about the upper bound is worth marks. Don't soften it.</a:t>
             </a:r>
           </a:p>
         </p:txBody>
@@ -734,7 +737,7 @@
           <a:lstStyle/>
           <a:p>
             <a:r>
-              <a:t>[12s  |  EITHER  |  ~22 words @ 110 wpm]</a:t>
+              <a:t>[12s  |  EITHER  |  ~29 words @ 145 wpm]</a:t>
             </a:r>
           </a:p>
           <a:p>
@@ -745,12 +748,17 @@
           <a:p/>
           <a:p>
             <a:r>
-              <a:t>All of that runs from one command, no API key, in about two minutes --</a:t>
-            </a:r>
-          </a:p>
-          <a:p>
-            <a:r>
-              <a:t>eighty-three tests and six acceptance checks. Questions?</a:t>
+              <a:t>All of that runs from a single command, with no API key, in about two minutes,</a:t>
+            </a:r>
+          </a:p>
+          <a:p>
+            <a:r>
+              <a:t>covering eighty-three tests and six acceptance checks. We are happy to take</a:t>
+            </a:r>
+          </a:p>
+          <a:p>
+            <a:r>
+              <a:t>questions.</a:t>
             </a:r>
           </a:p>
           <a:p/>
@@ -761,7 +769,7 @@
           </a:p>
           <a:p>
             <a:r>
-              <a:t>DELIVERY: Stop talking. Leave the full minute for Q&amp;A.</a:t>
+              <a:t>DELIVERY: Then stop talking. Leave the full minute for Q&amp;A.</a:t>
             </a:r>
           </a:p>
         </p:txBody>
@@ -831,7 +839,7 @@
           <a:lstStyle/>
           <a:p>
             <a:r>
-              <a:t>[0s  |  APPENDIX  |  ~123 words @ 0 wpm]</a:t>
+              <a:t>[0s  |  APPENDIX  |  ~177 words @ 0 wpm]</a:t>
             </a:r>
           </a:p>
           <a:p>
@@ -842,60 +850,74 @@
           <a:p/>
           <a:p>
             <a:r>
-              <a:t>Not presented -- backup for Q&amp;A on the AI element.</a:t>
+              <a:t>Not presented — this is backup in case we are asked about the AI element.</a:t>
             </a:r>
           </a:p>
           <a:p/>
           <a:p>
             <a:r>
-              <a:t>We predict the residual: actual arrival minus predicted arrival, applied as a</a:t>
-            </a:r>
-          </a:p>
-          <a:p>
-            <a:r>
-              <a:t>correction on top of the agency's ETA. Predicting zero is identical to trusting</a:t>
-            </a:r>
-          </a:p>
-          <a:p>
-            <a:r>
-              <a:t>the agency, so the baseline comparison is exact.</a:t>
+              <a:t>We predict the residual, which is the actual arrival minus the predicted arrival,</a:t>
+            </a:r>
+          </a:p>
+          <a:p>
+            <a:r>
+              <a:t>and we apply it as a correction on top of the agency's own estimate. Predicting</a:t>
+            </a:r>
+          </a:p>
+          <a:p>
+            <a:r>
+              <a:t>zero is identical to trusting the agency, so the baseline comparison is exact</a:t>
+            </a:r>
+          </a:p>
+          <a:p>
+            <a:r>
+              <a:t>rather than approximate. The interesting result is that both naive bias</a:t>
+            </a:r>
+          </a:p>
+          <a:p>
+            <a:r>
+              <a:t>corrections perform worse than doing nothing at all, because residuals are</a:t>
+            </a:r>
+          </a:p>
+          <a:p>
+            <a:r>
+              <a:t>heavily right-skewed, with a mean of plus 213 seconds against a median of plus</a:t>
+            </a:r>
+          </a:p>
+          <a:p>
+            <a:r>
+              <a:t>111, so adding the mean overcorrects the typical case. The model earns its</a:t>
+            </a:r>
+          </a:p>
+          <a:p>
+            <a:r>
+              <a:t>fourteen point seven percent improvement by learning a correction that depends on</a:t>
+            </a:r>
+          </a:p>
+          <a:p>
+            <a:r>
+              <a:t>horizon, hour and route rather than applying a constant.</a:t>
             </a:r>
           </a:p>
           <a:p/>
           <a:p>
             <a:r>
-              <a:t>The interesting result is that both naive bias corrections are WORSE than doing</a:t>
-            </a:r>
-          </a:p>
-          <a:p>
-            <a:r>
-              <a:t>nothing. Residuals are right-skewed -- mean plus 213 seconds, median plus 111 --</a:t>
-            </a:r>
-          </a:p>
-          <a:p>
-            <a:r>
-              <a:t>so adding the mean overcorrects the typical case. The model earns its 14.7% by</a:t>
-            </a:r>
-          </a:p>
-          <a:p>
-            <a:r>
-              <a:t>learning a horizon, hour and route dependent correction.</a:t>
-            </a:r>
-          </a:p>
-          <a:p/>
-          <a:p>
-            <a:r>
-              <a:t>On leakage: labels come from GPS, features from predictions. Different feeds, so</a:t>
-            </a:r>
-          </a:p>
-          <a:p>
-            <a:r>
-              <a:t>the label cannot contain the feature. We excluded lead-time because it contains</a:t>
-            </a:r>
-          </a:p>
-          <a:p>
-            <a:r>
-              <a:t>the target, and split strictly forward in time.</a:t>
+              <a:t>On leakage: our labels come from GPS positions and our features come from</a:t>
+            </a:r>
+          </a:p>
+          <a:p>
+            <a:r>
+              <a:t>predictions, so they are different feeds and the label cannot contain the</a:t>
+            </a:r>
+          </a:p>
+          <a:p>
+            <a:r>
+              <a:t>feature. We also excluded lead time as a feature because it contains the target,</a:t>
+            </a:r>
+          </a:p>
+          <a:p>
+            <a:r>
+              <a:t>and we split the data strictly forward in time rather than randomly.</a:t>
             </a:r>
           </a:p>
           <a:p/>
@@ -976,7 +998,7 @@
           <a:lstStyle/>
           <a:p>
             <a:r>
-              <a:t>[48s  |  BORNA  |  ~100 words @ 125 wpm]</a:t>
+              <a:t>[48s  |  BORNA  |  ~131 words @ 164 wpm]</a:t>
             </a:r>
           </a:p>
           <a:p>
@@ -987,56 +1009,63 @@
           <a:p/>
           <a:p>
             <a:r>
-              <a:t>Agencies publish two live feeds. TripUpdates is predictions -- a bus will</a:t>
-            </a:r>
-          </a:p>
-          <a:p>
-            <a:r>
-              <a:t>reach stop 22 at 15:07. VehiclePositions is GPS -- bus 4821 is here, now.</a:t>
+              <a:t>Transit agencies publish two live feeds, and between them you would think this</a:t>
+            </a:r>
+          </a:p>
+          <a:p>
+            <a:r>
+              <a:t>question was already answered. TripUpdates gives you predictions: a bus will</a:t>
+            </a:r>
+          </a:p>
+          <a:p>
+            <a:r>
+              <a:t>reach stop 22 at 15:07. VehiclePositions gives you GPS: bus 4821 is at this</a:t>
+            </a:r>
+          </a:p>
+          <a:p>
+            <a:r>
+              <a:t>coordinate right now. But notice what neither of them ever says, which is that</a:t>
+            </a:r>
+          </a:p>
+          <a:p>
+            <a:r>
+              <a:t>the bus actually arrived. That fact is not published by anyone, so it has to be</a:t>
+            </a:r>
+          </a:p>
+          <a:p>
+            <a:r>
+              <a:t>derived from indirect evidence. And that is what makes this hard rather than</a:t>
+            </a:r>
+          </a:p>
+          <a:p>
+            <a:r>
+              <a:t>tedious, because delay is actual minus scheduled, the scheduled time is published</a:t>
+            </a:r>
+          </a:p>
+          <a:p>
+            <a:r>
+              <a:t>and exact, so every bit of error in our derived actual goes straight into the</a:t>
+            </a:r>
+          </a:p>
+          <a:p>
+            <a:r>
+              <a:t>delay figure with nothing downstream able to catch it. Our user is a rider</a:t>
+            </a:r>
+          </a:p>
+          <a:p>
+            <a:r>
+              <a:t>deciding whether to trust the estimate in their app.</a:t>
             </a:r>
           </a:p>
           <a:p/>
           <a:p>
             <a:r>
-              <a:t>Notice what is missing: neither feed ever says the bus ARRIVED. Nobody publishes</a:t>
-            </a:r>
-          </a:p>
-          <a:p>
-            <a:r>
-              <a:t>that. It has to be derived.</a:t>
-            </a:r>
-          </a:p>
-          <a:p/>
-          <a:p>
-            <a:r>
-              <a:t>And here is why that is hard rather than tedious. Delay equals actual minus</a:t>
-            </a:r>
-          </a:p>
-          <a:p>
-            <a:r>
-              <a:t>scheduled. Scheduled is published and exact. So every bit of error in our derived</a:t>
-            </a:r>
-          </a:p>
-          <a:p>
-            <a:r>
-              <a:t>actual goes straight into the delay number, and nothing downstream can catch it.</a:t>
-            </a:r>
-          </a:p>
-          <a:p/>
-          <a:p>
-            <a:r>
-              <a:t>Our user is a rider deciding whether to trust the ETA in their app.</a:t>
-            </a:r>
-          </a:p>
-          <a:p/>
-          <a:p>
-            <a:r>
               <a:t>--------------------------------------------------------------</a:t>
             </a:r>
           </a:p>
           <a:p>
             <a:r>
-              <a:t>DELIVERY: Slow on the last sentence of paragraph three -- it justifies the whole project.</a:t>
+              <a:t>DELIVERY: Slow down from 'And that is what makes this hard' — it justifies everything after.</a:t>
             </a:r>
           </a:p>
         </p:txBody>
@@ -1106,7 +1135,7 @@
           <a:lstStyle/>
           <a:p>
             <a:r>
-              <a:t>[36s  |  BORNA  |  ~70 words @ 117 wpm]</a:t>
+              <a:t>[36s  |  BORNA  |  ~88 words @ 147 wpm]</a:t>
             </a:r>
           </a:p>
           <a:p>
@@ -1117,45 +1146,48 @@
           <a:p/>
           <a:p>
             <a:r>
-              <a:t>This is the whole talk in one picture, and we will walk it left to right.</a:t>
+              <a:t>This is the whole talk in one picture, and we are going to walk it left to</a:t>
+            </a:r>
+          </a:p>
+          <a:p>
+            <a:r>
+              <a:t>right. 511 gives us protobuf over HTTP. A poller writes those bytes straight to</a:t>
+            </a:r>
+          </a:p>
+          <a:p>
+            <a:r>
+              <a:t>disk. A producer then decodes them, validates every record, and publishes to</a:t>
+            </a:r>
+          </a:p>
+          <a:p>
+            <a:r>
+              <a:t>Kafka. A resolver turns GPS observations into arrivals, an aggregator joins those</a:t>
+            </a:r>
+          </a:p>
+          <a:p>
+            <a:r>
+              <a:t>arrivals back against the original predictions, and that produces our answer.</a:t>
+            </a:r>
+          </a:p>
+          <a:p>
+            <a:r>
+              <a:t>Finally a model learns the correction. Nine stages in total, and I will take the</a:t>
+            </a:r>
+          </a:p>
+          <a:p>
+            <a:r>
+              <a:t>first four while Aatish takes the rest.</a:t>
             </a:r>
           </a:p>
           <a:p/>
           <a:p>
             <a:r>
-              <a:t>511 gives us protobuf. A poller writes it to disk. A producer validates it and</a:t>
-            </a:r>
-          </a:p>
-          <a:p>
-            <a:r>
-              <a:t>publishes to Kafka. A resolver turns GPS into arrivals. An aggregator joins those</a:t>
-            </a:r>
-          </a:p>
-          <a:p>
-            <a:r>
-              <a:t>against the predictions, and that produces our answer. A model then learns the</a:t>
-            </a:r>
-          </a:p>
-          <a:p>
-            <a:r>
-              <a:t>correction.</a:t>
-            </a:r>
-          </a:p>
-          <a:p/>
-          <a:p>
-            <a:r>
-              <a:t>Nine stages. I will take the first four, Aatish takes the rest.</a:t>
-            </a:r>
-          </a:p>
-          <a:p/>
-          <a:p>
-            <a:r>
               <a:t>--------------------------------------------------------------</a:t>
             </a:r>
           </a:p>
           <a:p>
             <a:r>
-              <a:t>DELIVERY: Point along the diagram as you speak. Do not read every box.</a:t>
+              <a:t>DELIVERY: Point along the diagram as you go. Don't read every box aloud.</a:t>
             </a:r>
           </a:p>
         </p:txBody>
@@ -1225,7 +1257,7 @@
           <a:lstStyle/>
           <a:p>
             <a:r>
-              <a:t>[40s  |  BORNA  |  ~80 words @ 120 wpm]</a:t>
+              <a:t>[40s  |  BORNA  |  ~111 words @ 166 wpm]</a:t>
             </a:r>
           </a:p>
           <a:p>
@@ -1236,50 +1268,53 @@
           <a:p/>
           <a:p>
             <a:r>
-              <a:t>Stages one and two. One consolidated 511 feed covers all 28 Bay Area</a:t>
-            </a:r>
-          </a:p>
-          <a:p>
-            <a:r>
-              <a:t>operators -- which matters, because our quota is sixty requests an hour, so we can</a:t>
-            </a:r>
-          </a:p>
-          <a:p>
-            <a:r>
-              <a:t>only afford one poll every two minutes.</a:t>
+              <a:t>Stages one and two. Our source is a single consolidated 511 feed covering all</a:t>
+            </a:r>
+          </a:p>
+          <a:p>
+            <a:r>
+              <a:t>twenty-eight Bay Area operators in one request, and that matters more than it</a:t>
+            </a:r>
+          </a:p>
+          <a:p>
+            <a:r>
+              <a:t>sounds, because our quota is sixty requests an hour, which means we can only</a:t>
+            </a:r>
+          </a:p>
+          <a:p>
+            <a:r>
+              <a:t>afford one poll every two minutes. The poller itself has one rule that everything</a:t>
+            </a:r>
+          </a:p>
+          <a:p>
+            <a:r>
+              <a:t>downstream depends on, which is to write the raw bytes to disk before attempting</a:t>
+            </a:r>
+          </a:p>
+          <a:p>
+            <a:r>
+              <a:t>to decode them. A decoding bug is recoverable, because the file is still there</a:t>
+            </a:r>
+          </a:p>
+          <a:p>
+            <a:r>
+              <a:t>and we can reprocess it. A poll we never took is gone forever, because there is</a:t>
+            </a:r>
+          </a:p>
+          <a:p>
+            <a:r>
+              <a:t>no history endpoint. So we make the irreversible step the cheap one.</a:t>
             </a:r>
           </a:p>
           <a:p/>
           <a:p>
             <a:r>
-              <a:t>The poller has one rule: write the raw bytes to disk BEFORE trying to decode</a:t>
-            </a:r>
-          </a:p>
-          <a:p>
-            <a:r>
-              <a:t>them. A decoding bug is recoverable -- reprocess the file. A poll never taken is</a:t>
-            </a:r>
-          </a:p>
-          <a:p>
-            <a:r>
-              <a:t>gone forever, because there is no history endpoint.</a:t>
-            </a:r>
-          </a:p>
-          <a:p/>
-          <a:p>
-            <a:r>
-              <a:t>Make the irreversible step the cheap one.</a:t>
-            </a:r>
-          </a:p>
-          <a:p/>
-          <a:p>
-            <a:r>
               <a:t>--------------------------------------------------------------</a:t>
             </a:r>
           </a:p>
           <a:p>
             <a:r>
-              <a:t>DELIVERY: The 'irreversible step' line is the memorable one. Pause after it.</a:t>
+              <a:t>DELIVERY: Pause after the last sentence — it is the line people remember.</a:t>
             </a:r>
           </a:p>
         </p:txBody>
@@ -1349,7 +1384,7 @@
           <a:lstStyle/>
           <a:p>
             <a:r>
-              <a:t>[48s  |  BORNA  |  ~103 words @ 129 wpm]</a:t>
+              <a:t>[48s  |  BORNA  |  ~133 words @ 166 wpm]</a:t>
             </a:r>
           </a:p>
           <a:p>
@@ -1360,61 +1395,63 @@
           <a:p/>
           <a:p>
             <a:r>
-              <a:t>Stages three and four. The archive on disk is our system of record.</a:t>
+              <a:t>Stages three and four. The archive on disk is our system of record, and</a:t>
+            </a:r>
+          </a:p>
+          <a:p>
+            <a:r>
+              <a:t>everything downstream reads from it. On the right is one real record as it enters</a:t>
+            </a:r>
+          </a:p>
+          <a:p>
+            <a:r>
+              <a:t>Kafka, after validation. The key is service date plus trip ID, and the date is in</a:t>
+            </a:r>
+          </a:p>
+          <a:p>
+            <a:r>
+              <a:t>there because trip IDs repeat every single day, so yesterday's version of this</a:t>
+            </a:r>
+          </a:p>
+          <a:p>
+            <a:r>
+              <a:t>trip is genuinely a different journey. Now look at arrival uncertainty, because</a:t>
+            </a:r>
+          </a:p>
+          <a:p>
+            <a:r>
+              <a:t>it is null rather than zero. Protobuf lets a field be genuinely absent, and</a:t>
+            </a:r>
+          </a:p>
+          <a:p>
+            <a:r>
+              <a:t>absent means something quite different from zero. Zero means the vehicle is</a:t>
+            </a:r>
+          </a:p>
+          <a:p>
+            <a:r>
+              <a:t>exactly on time. Absent means the agency told us nothing at all. Forty-four</a:t>
+            </a:r>
+          </a:p>
+          <a:p>
+            <a:r>
+              <a:t>percent of records carry no delay value, and read the obvious way we would have</a:t>
+            </a:r>
+          </a:p>
+          <a:p>
+            <a:r>
+              <a:t>called every single one of them perfectly on time.</a:t>
             </a:r>
           </a:p>
           <a:p/>
           <a:p>
             <a:r>
-              <a:t>On the right is one real record as it enters Kafka, after validation. Note the</a:t>
-            </a:r>
-          </a:p>
-          <a:p>
-            <a:r>
-              <a:t>key: service date plus trip ID. The date is there because trip IDs repeat every</a:t>
-            </a:r>
-          </a:p>
-          <a:p>
-            <a:r>
-              <a:t>single day.</a:t>
-            </a:r>
-          </a:p>
-          <a:p/>
-          <a:p>
-            <a:r>
-              <a:t>And look at arrival_uncertainty -- it is null, not zero. Protobuf lets a field be</a:t>
-            </a:r>
-          </a:p>
-          <a:p>
-            <a:r>
-              <a:t>genuinely absent, and absent is different from zero. Zero means exactly on time.</a:t>
-            </a:r>
-          </a:p>
-          <a:p>
-            <a:r>
-              <a:t>Absent means the agency told us nothing.</a:t>
-            </a:r>
-          </a:p>
-          <a:p/>
-          <a:p>
-            <a:r>
-              <a:t>Forty-four percent of records have no delay value. Read the obvious way, we would</a:t>
-            </a:r>
-          </a:p>
-          <a:p>
-            <a:r>
-              <a:t>have called every one of them perfectly on time.</a:t>
-            </a:r>
-          </a:p>
-          <a:p/>
-          <a:p>
-            <a:r>
               <a:t>--------------------------------------------------------------</a:t>
             </a:r>
           </a:p>
           <a:p>
             <a:r>
-              <a:t>DELIVERY: This covers the contract AND the 44% finding. Land 'perfectly on time', then hand over.</a:t>
+              <a:t>DELIVERY: Land 'perfectly on time', pause, then hand over to Aatish.</a:t>
             </a:r>
           </a:p>
         </p:txBody>
@@ -1484,7 +1521,7 @@
           <a:lstStyle/>
           <a:p>
             <a:r>
-              <a:t>[44s  |  AATISH  |  ~94 words @ 128 wpm]</a:t>
+              <a:t>[44s  |  AATISH  |  ~122 words @ 166 wpm]</a:t>
             </a:r>
           </a:p>
           <a:p>
@@ -1495,61 +1532,63 @@
           <a:p/>
           <a:p>
             <a:r>
-              <a:t>Stage five, Kafka. Four topics, three partitions each.</a:t>
+              <a:t>Stage five is Kafka. Four topics, three partitions each, and two of these</a:t>
+            </a:r>
+          </a:p>
+          <a:p>
+            <a:r>
+              <a:t>settings are worth explaining. Retention is twenty-four hours, and that is</a:t>
+            </a:r>
+          </a:p>
+          <a:p>
+            <a:r>
+              <a:t>deliberate, because Kafka is transport for us rather than storage, and the</a:t>
+            </a:r>
+          </a:p>
+          <a:p>
+            <a:r>
+              <a:t>archive Borna just described is what we actually keep. The cleanup policy is</a:t>
+            </a:r>
+          </a:p>
+          <a:p>
+            <a:r>
+              <a:t>delete and never compact, and that one genuinely matters, because compaction</a:t>
+            </a:r>
+          </a:p>
+          <a:p>
+            <a:r>
+              <a:t>keeps only the newest message per key and discards the rest, but our data is the</a:t>
+            </a:r>
+          </a:p>
+          <a:p>
+            <a:r>
+              <a:t>history. We detect arrivals by watching a vehicle change state across consecutive</a:t>
+            </a:r>
+          </a:p>
+          <a:p>
+            <a:r>
+              <a:t>observations, so compaction would throw away precisely the thing we read. And the</a:t>
+            </a:r>
+          </a:p>
+          <a:p>
+            <a:r>
+              <a:t>message key puts every observation of one trip into one partition, in order,</a:t>
+            </a:r>
+          </a:p>
+          <a:p>
+            <a:r>
+              <a:t>which turns out to be the whole game.</a:t>
             </a:r>
           </a:p>
           <a:p/>
           <a:p>
             <a:r>
-              <a:t>Two settings worth explaining. Retention is twenty-four hours, deliberately --</a:t>
-            </a:r>
-          </a:p>
-          <a:p>
-            <a:r>
-              <a:t>Kafka is transport, not storage. The archive Borna described is what we keep.</a:t>
-            </a:r>
-          </a:p>
-          <a:p/>
-          <a:p>
-            <a:r>
-              <a:t>And cleanup policy is delete, never compact. Compaction keeps only the newest</a:t>
-            </a:r>
-          </a:p>
-          <a:p>
-            <a:r>
-              <a:t>message per key. Our data IS the history -- we detect arrivals by watching a</a:t>
-            </a:r>
-          </a:p>
-          <a:p>
-            <a:r>
-              <a:t>vehicle change state across consecutive observations, so compaction would throw</a:t>
-            </a:r>
-          </a:p>
-          <a:p>
-            <a:r>
-              <a:t>away exactly what we read.</a:t>
-            </a:r>
-          </a:p>
-          <a:p/>
-          <a:p>
-            <a:r>
-              <a:t>The key puts every observation of one trip in one partition, in order. That turns</a:t>
-            </a:r>
-          </a:p>
-          <a:p>
-            <a:r>
-              <a:t>out to be the whole game.</a:t>
-            </a:r>
-          </a:p>
-          <a:p/>
-          <a:p>
-            <a:r>
               <a:t>--------------------------------------------------------------</a:t>
             </a:r>
           </a:p>
           <a:p>
             <a:r>
-              <a:t>DELIVERY: Ends on the key. That sets up the next slide directly.</a:t>
+              <a:t>DELIVERY: Ending on the key sets up the next slide directly.</a:t>
             </a:r>
           </a:p>
         </p:txBody>
@@ -1619,7 +1658,7 @@
           <a:lstStyle/>
           <a:p>
             <a:r>
-              <a:t>[50s  |  AATISH  |  ~103 words @ 124 wpm]</a:t>
+              <a:t>[50s  |  AATISH  |  ~133 words @ 160 wpm]</a:t>
             </a:r>
           </a:p>
           <a:p>
@@ -1630,66 +1669,63 @@
           <a:p/>
           <a:p>
             <a:r>
-              <a:t>Stage six, and this is the heart of it.</a:t>
+              <a:t>Stage six, and this is the heart of the project. Here is one real vehicle, a</a:t>
+            </a:r>
+          </a:p>
+          <a:p>
+            <a:r>
+              <a:t>Powell-Mason cable car, and across four consecutive polls you can watch it</a:t>
+            </a:r>
+          </a:p>
+          <a:p>
+            <a:r>
+              <a:t>approach stop four, then report STOPPED_AT at stop four, and then move on to stop</a:t>
+            </a:r>
+          </a:p>
+          <a:p>
+            <a:r>
+              <a:t>six. That transition is the arrival, and that sentence exists nowhere in the</a:t>
+            </a:r>
+          </a:p>
+          <a:p>
+            <a:r>
+              <a:t>source data. We derived it. The subtlety is that it is the first stopped</a:t>
+            </a:r>
+          </a:p>
+          <a:p>
+            <a:r>
+              <a:t>sighting, not the last, because a parked vehicle keeps reporting STOPPED_AT on</a:t>
+            </a:r>
+          </a:p>
+          <a:p>
+            <a:r>
+              <a:t>every poll while it waits. So if you took the last one you would be measuring</a:t>
+            </a:r>
+          </a:p>
+          <a:p>
+            <a:r>
+              <a:t>departure rather than arrival, and nothing would ever tell you that you had it</a:t>
+            </a:r>
+          </a:p>
+          <a:p>
+            <a:r>
+              <a:t>wrong. Which means the resolver has to remember what it saw before, and that is</a:t>
+            </a:r>
+          </a:p>
+          <a:p>
+            <a:r>
+              <a:t>exactly why the ordering guarantee matters.</a:t>
             </a:r>
           </a:p>
           <a:p/>
           <a:p>
             <a:r>
-              <a:t>Here is one real vehicle -- a Powell-Mason cable car. Across four consecutive</a:t>
-            </a:r>
-          </a:p>
-          <a:p>
-            <a:r>
-              <a:t>polls you can watch it approach stop four, report STOPPED_AT stop four, and then</a:t>
-            </a:r>
-          </a:p>
-          <a:p>
-            <a:r>
-              <a:t>move on.</a:t>
-            </a:r>
-          </a:p>
-          <a:p/>
-          <a:p>
-            <a:r>
-              <a:t>That transition is the arrival. It exists nowhere in the source data; we derived</a:t>
-            </a:r>
-          </a:p>
-          <a:p>
-            <a:r>
-              <a:t>it.</a:t>
-            </a:r>
-          </a:p>
-          <a:p/>
-          <a:p>
-            <a:r>
-              <a:t>The subtlety: it is the FIRST stopped sighting. A parked vehicle reports that</a:t>
-            </a:r>
-          </a:p>
-          <a:p>
-            <a:r>
-              <a:t>status on every poll while it waits, so taking the last one would measure</a:t>
-            </a:r>
-          </a:p>
-          <a:p>
-            <a:r>
-              <a:t>departure -- and nothing would ever tell you. Which means the resolver holds</a:t>
-            </a:r>
-          </a:p>
-          <a:p>
-            <a:r>
-              <a:t>per-trip state, and that is why the ordering guarantee matters.</a:t>
-            </a:r>
-          </a:p>
-          <a:p/>
-          <a:p>
-            <a:r>
               <a:t>--------------------------------------------------------------</a:t>
             </a:r>
           </a:p>
           <a:p>
             <a:r>
-              <a:t>DELIVERY: This is the rubric's 'one concrete example'. Trace the four lines with your finger.</a:t>
+              <a:t>DELIVERY: The rubric asks for one concrete example. Trace the four lines with your finger.</a:t>
             </a:r>
           </a:p>
         </p:txBody>
@@ -1759,7 +1795,7 @@
           <a:lstStyle/>
           <a:p>
             <a:r>
-              <a:t>[43s  |  AATISH  |  ~89 words @ 124 wpm]</a:t>
+              <a:t>[43s  |  AATISH  |  ~104 words @ 145 wpm]</a:t>
             </a:r>
           </a:p>
           <a:p>
@@ -1770,61 +1806,58 @@
           <a:p/>
           <a:p>
             <a:r>
-              <a:t>Stages seven and eight. We join our derived arrivals against what the agency</a:t>
-            </a:r>
-          </a:p>
-          <a:p>
-            <a:r>
-              <a:t>predicted.</a:t>
+              <a:t>Stages seven and eight. Now we join our derived arrivals against what the</a:t>
+            </a:r>
+          </a:p>
+          <a:p>
+            <a:r>
+              <a:t>agency actually predicted. For that same cable car, two minutes ahead of time</a:t>
+            </a:r>
+          </a:p>
+          <a:p>
+            <a:r>
+              <a:t>Muni predicted 14:53:54, and it arrived at 14:54:31, so thirty-seven seconds</a:t>
+            </a:r>
+          </a:p>
+          <a:p>
+            <a:r>
+              <a:t>later than promised. That is one data point, and the pipeline produces</a:t>
+            </a:r>
+          </a:p>
+          <a:p>
+            <a:r>
+              <a:t>twenty-five thousand of them. Aggregated, the close-in predictions are genuinely</a:t>
+            </a:r>
+          </a:p>
+          <a:p>
+            <a:r>
+              <a:t>excellent, around thirteen seconds off. But at twenty minutes out only</a:t>
+            </a:r>
+          </a:p>
+          <a:p>
+            <a:r>
+              <a:t>twenty-three percent land within a minute, and the bias is negative at every</a:t>
+            </a:r>
+          </a:p>
+          <a:p>
+            <a:r>
+              <a:t>horizon, meaning vehicles consistently arrive later than promised. This is only</a:t>
+            </a:r>
+          </a:p>
+          <a:p>
+            <a:r>
+              <a:t>credible because the two halves come from completely different feeds.</a:t>
             </a:r>
           </a:p>
           <a:p/>
           <a:p>
             <a:r>
-              <a:t>For that same cable car: two minutes ahead, Muni predicted 14:53:54. It arrived</a:t>
-            </a:r>
-          </a:p>
-          <a:p>
-            <a:r>
-              <a:t>at 14:54:31 -- thirty-seven seconds late. That is one data point; the pipeline</a:t>
-            </a:r>
-          </a:p>
-          <a:p>
-            <a:r>
-              <a:t>produces twenty-five thousand of them.</a:t>
-            </a:r>
-          </a:p>
-          <a:p/>
-          <a:p>
-            <a:r>
-              <a:t>Aggregated, close-in predictions are excellent -- thirteen seconds off. At twenty</a:t>
-            </a:r>
-          </a:p>
-          <a:p>
-            <a:r>
-              <a:t>minutes out, only twenty-three percent land within a minute, and the bias is</a:t>
-            </a:r>
-          </a:p>
-          <a:p>
-            <a:r>
-              <a:t>negative throughout, meaning vehicles arrive later than promised.</a:t>
-            </a:r>
-          </a:p>
-          <a:p/>
-          <a:p>
-            <a:r>
-              <a:t>This is credible only because the two halves come from different feeds.</a:t>
-            </a:r>
-          </a:p>
-          <a:p/>
-          <a:p>
-            <a:r>
               <a:t>--------------------------------------------------------------</a:t>
             </a:r>
           </a:p>
           <a:p>
             <a:r>
-              <a:t>DELIVERY: Read ONE row of the table, not five. The independence point is the real content.</a:t>
+              <a:t>DELIVERY: Read one row of the table aloud, not five. The independence point is the content.</a:t>
             </a:r>
           </a:p>
         </p:txBody>
@@ -1894,7 +1927,7 @@
           <a:lstStyle/>
           <a:p>
             <a:r>
-              <a:t>[36s  |  AATISH  |  ~73 words @ 122 wpm]</a:t>
+              <a:t>[36s  |  AATISH  |  ~100 words @ 167 wpm]</a:t>
             </a:r>
           </a:p>
           <a:p>
@@ -1905,50 +1938,53 @@
           <a:p/>
           <a:p>
             <a:r>
-              <a:t>Our best lesson came from a feature we deleted.</a:t>
+              <a:t>Our best lesson came from a feature we deleted. Day of week improved our test</a:t>
+            </a:r>
+          </a:p>
+          <a:p>
+            <a:r>
+              <a:t>error by ten seconds, and we removed it anyway. The reason is that Monday</a:t>
+            </a:r>
+          </a:p>
+          <a:p>
+            <a:r>
+              <a:t>appeared only in our test window, so thirty-one percent of test rows carried a</a:t>
+            </a:r>
+          </a:p>
+          <a:p>
+            <a:r>
+              <a:t>value the model had never seen during training, and those rows quietly inherited</a:t>
+            </a:r>
+          </a:p>
+          <a:p>
+            <a:r>
+              <a:t>an adjacent day's correction through wherever the bin boundaries happened to</a:t>
+            </a:r>
+          </a:p>
+          <a:p>
+            <a:r>
+              <a:t>fall. The gain was an artifact rather than learned structure. And every real bug</a:t>
+            </a:r>
+          </a:p>
+          <a:p>
+            <a:r>
+              <a:t>we hit had that same shape: none of them crashed, and several produced</a:t>
+            </a:r>
+          </a:p>
+          <a:p>
+            <a:r>
+              <a:t>better-looking numbers than the correct version.</a:t>
             </a:r>
           </a:p>
           <a:p/>
           <a:p>
             <a:r>
-              <a:t>Day-of-week improved our test error by ten seconds. We removed it anyway, because</a:t>
-            </a:r>
-          </a:p>
-          <a:p>
-            <a:r>
-              <a:t>Monday appeared only in our test window -- thirty-one percent of test rows had a</a:t>
-            </a:r>
-          </a:p>
-          <a:p>
-            <a:r>
-              <a:t>value the model had never seen, so they inherited an adjacent day's correction</a:t>
-            </a:r>
-          </a:p>
-          <a:p>
-            <a:r>
-              <a:t>through where the bins happened to fall.</a:t>
-            </a:r>
-          </a:p>
-          <a:p/>
-          <a:p>
-            <a:r>
-              <a:t>Every real bug we hit had that shape. None of them crashed. Several produced</a:t>
-            </a:r>
-          </a:p>
-          <a:p>
-            <a:r>
-              <a:t>better-looking numbers.</a:t>
-            </a:r>
-          </a:p>
-          <a:p/>
-          <a:p>
-            <a:r>
               <a:t>--------------------------------------------------------------</a:t>
             </a:r>
           </a:p>
           <a:p>
             <a:r>
-              <a:t>DELIVERY: Pause after 'we removed it anyway'. Let the oddity register.</a:t>
+              <a:t>DELIVERY: Pause after 'we removed it anyway' and let the oddity register.</a:t>
             </a:r>
           </a:p>
         </p:txBody>

</xml_diff>

<commit_message>
Trim speaker scripts to a comfortable read-aloud pace
</commit_message>
<xml_diff>
--- a/Final_Presentation_Pipeline_Karimi_Lobo.pptx
+++ b/Final_Presentation_Pipeline_Karimi_Lobo.pptx
@@ -610,7 +610,7 @@
           <a:lstStyle/>
           <a:p>
             <a:r>
-              <a:t>[38s  |  AATISH  |  ~108 words @ 171 wpm]</a:t>
+              <a:t>[38s  |  AATISH  |  ~88 words @ 139 wpm]</a:t>
             </a:r>
           </a:p>
           <a:p>
@@ -626,37 +626,32 @@
           </a:p>
           <a:p>
             <a:r>
-              <a:t>percent of stop events. Vehicles dwell at a stop for a matter of seconds while we</a:t>
-            </a:r>
-          </a:p>
-          <a:p>
-            <a:r>
-              <a:t>sample every two minutes. And it is not random either, since the chance of</a:t>
-            </a:r>
-          </a:p>
-          <a:p>
-            <a:r>
-              <a:t>catching a stop scales with how long the vehicle sits there, so terminals and</a:t>
-            </a:r>
-          </a:p>
-          <a:p>
-            <a:r>
-              <a:t>layovers end up over-represented and our derived arrivals skew late. That means</a:t>
-            </a:r>
-          </a:p>
-          <a:p>
-            <a:r>
-              <a:t>the optimism we measured should be read as an upper bound rather than a point</a:t>
-            </a:r>
-          </a:p>
-          <a:p>
-            <a:r>
-              <a:t>estimate. So our next step is deliberately small: one email to 511 requesting a</a:t>
-            </a:r>
-          </a:p>
-          <a:p>
-            <a:r>
-              <a:t>higher rate limit, which attacks all three of those problems at once.</a:t>
+              <a:t>percent of stop events, because vehicles dwell for seconds while we sample every</a:t>
+            </a:r>
+          </a:p>
+          <a:p>
+            <a:r>
+              <a:t>two minutes. And it is not random, since the chance of catching a stop scales</a:t>
+            </a:r>
+          </a:p>
+          <a:p>
+            <a:r>
+              <a:t>with dwell time, so terminals are over-represented and our arrivals skew late.</a:t>
+            </a:r>
+          </a:p>
+          <a:p>
+            <a:r>
+              <a:t>That means the optimism we measured is an upper bound, not a point estimate. So</a:t>
+            </a:r>
+          </a:p>
+          <a:p>
+            <a:r>
+              <a:t>our next step is deliberately small: one email to 511 requesting a higher rate</a:t>
+            </a:r>
+          </a:p>
+          <a:p>
+            <a:r>
+              <a:t>limit, which attacks all three problems at once.</a:t>
             </a:r>
           </a:p>
           <a:p/>
@@ -998,7 +993,7 @@
           <a:lstStyle/>
           <a:p>
             <a:r>
-              <a:t>[48s  |  BORNA  |  ~131 words @ 164 wpm]</a:t>
+              <a:t>[48s  |  BORNA  |  ~120 words @ 150 wpm]</a:t>
             </a:r>
           </a:p>
           <a:p>
@@ -1009,12 +1004,7 @@
           <a:p/>
           <a:p>
             <a:r>
-              <a:t>Transit agencies publish two live feeds, and between them you would think this</a:t>
-            </a:r>
-          </a:p>
-          <a:p>
-            <a:r>
-              <a:t>question was already answered. TripUpdates gives you predictions: a bus will</a:t>
+              <a:t>Transit agencies publish two live feeds. TripUpdates gives you predictions: a bus will</a:t>
             </a:r>
           </a:p>
           <a:p>
@@ -1257,7 +1247,7 @@
           <a:lstStyle/>
           <a:p>
             <a:r>
-              <a:t>[40s  |  BORNA  |  ~111 words @ 166 wpm]</a:t>
+              <a:t>[40s  |  BORNA  |  ~98 words @ 147 wpm]</a:t>
             </a:r>
           </a:p>
           <a:p>
@@ -1273,27 +1263,22 @@
           </a:p>
           <a:p>
             <a:r>
-              <a:t>twenty-eight Bay Area operators in one request, and that matters more than it</a:t>
-            </a:r>
-          </a:p>
-          <a:p>
-            <a:r>
-              <a:t>sounds, because our quota is sixty requests an hour, which means we can only</a:t>
-            </a:r>
-          </a:p>
-          <a:p>
-            <a:r>
-              <a:t>afford one poll every two minutes. The poller itself has one rule that everything</a:t>
-            </a:r>
-          </a:p>
-          <a:p>
-            <a:r>
-              <a:t>downstream depends on, which is to write the raw bytes to disk before attempting</a:t>
-            </a:r>
-          </a:p>
-          <a:p>
-            <a:r>
-              <a:t>to decode them. A decoding bug is recoverable, because the file is still there</a:t>
+              <a:t>twenty-eight Bay Area operators in one request, and that matters because our</a:t>
+            </a:r>
+          </a:p>
+          <a:p>
+            <a:r>
+              <a:t>quota is sixty requests an hour, which means one poll every two minutes. The</a:t>
+            </a:r>
+          </a:p>
+          <a:p>
+            <a:r>
+              <a:t>poller then has one rule everything depends on: write the raw bytes to disk</a:t>
+            </a:r>
+          </a:p>
+          <a:p>
+            <a:r>
+              <a:t>before attempting to decode them. A decoding bug is recoverable, because the file is still there</a:t>
             </a:r>
           </a:p>
           <a:p>
@@ -1384,7 +1369,7 @@
           <a:lstStyle/>
           <a:p>
             <a:r>
-              <a:t>[48s  |  BORNA  |  ~133 words @ 166 wpm]</a:t>
+              <a:t>[48s  |  BORNA  |  ~122 words @ 152 wpm]</a:t>
             </a:r>
           </a:p>
           <a:p>
@@ -1410,17 +1395,12 @@
           </a:p>
           <a:p>
             <a:r>
-              <a:t>there because trip IDs repeat every single day, so yesterday's version of this</a:t>
-            </a:r>
-          </a:p>
-          <a:p>
-            <a:r>
-              <a:t>trip is genuinely a different journey. Now look at arrival uncertainty, because</a:t>
-            </a:r>
-          </a:p>
-          <a:p>
-            <a:r>
-              <a:t>it is null rather than zero. Protobuf lets a field be genuinely absent, and</a:t>
+              <a:t>there because trip IDs repeat every single day. Now look at arrival uncertainty,</a:t>
+            </a:r>
+          </a:p>
+          <a:p>
+            <a:r>
+              <a:t>because it is null rather than zero. Protobuf lets a field be genuinely absent, and</a:t>
             </a:r>
           </a:p>
           <a:p>
@@ -1521,7 +1501,7 @@
           <a:lstStyle/>
           <a:p>
             <a:r>
-              <a:t>[44s  |  AATISH  |  ~122 words @ 166 wpm]</a:t>
+              <a:t>[44s  |  AATISH  |  ~117 words @ 160 wpm]</a:t>
             </a:r>
           </a:p>
           <a:p>
@@ -1552,17 +1532,12 @@
           </a:p>
           <a:p>
             <a:r>
-              <a:t>delete and never compact, and that one genuinely matters, because compaction</a:t>
-            </a:r>
-          </a:p>
-          <a:p>
-            <a:r>
-              <a:t>keeps only the newest message per key and discards the rest, but our data is the</a:t>
-            </a:r>
-          </a:p>
-          <a:p>
-            <a:r>
-              <a:t>history. We detect arrivals by watching a vehicle change state across consecutive</a:t>
+              <a:t>delete and never compact, because compaction keeps only the newest message per</a:t>
+            </a:r>
+          </a:p>
+          <a:p>
+            <a:r>
+              <a:t>key and discards the rest, but our data is the history. We detect arrivals by watching a vehicle change state across consecutive</a:t>
             </a:r>
           </a:p>
           <a:p>
@@ -1927,7 +1902,7 @@
           <a:lstStyle/>
           <a:p>
             <a:r>
-              <a:t>[36s  |  AATISH  |  ~100 words @ 167 wpm]</a:t>
+              <a:t>[36s  |  AATISH  |  ~92 words @ 153 wpm]</a:t>
             </a:r>
           </a:p>
           <a:p>
@@ -1953,27 +1928,22 @@
           </a:p>
           <a:p>
             <a:r>
-              <a:t>value the model had never seen during training, and those rows quietly inherited</a:t>
-            </a:r>
-          </a:p>
-          <a:p>
-            <a:r>
-              <a:t>an adjacent day's correction through wherever the bin boundaries happened to</a:t>
-            </a:r>
-          </a:p>
-          <a:p>
-            <a:r>
-              <a:t>fall. The gain was an artifact rather than learned structure. And every real bug</a:t>
-            </a:r>
-          </a:p>
-          <a:p>
-            <a:r>
-              <a:t>we hit had that same shape: none of them crashed, and several produced</a:t>
-            </a:r>
-          </a:p>
-          <a:p>
-            <a:r>
-              <a:t>better-looking numbers than the correct version.</a:t>
+              <a:t>value the model had never seen in training, so they quietly inherited an adjacent</a:t>
+            </a:r>
+          </a:p>
+          <a:p>
+            <a:r>
+              <a:t>day's correction through wherever the bin boundaries fell. The gain was an</a:t>
+            </a:r>
+          </a:p>
+          <a:p>
+            <a:r>
+              <a:t>artifact, not learned structure. Every real bug we hit had that shape: none</a:t>
+            </a:r>
+          </a:p>
+          <a:p>
+            <a:r>
+              <a:t>crashed, and several produced better-looking numbers than the correct version.</a:t>
             </a:r>
           </a:p>
           <a:p/>

</xml_diff>

<commit_message>
Fix slide 5 orientation; refocus slide 6 on topics and partitions; clarify read vs derived on slide 7
</commit_message>
<xml_diff>
--- a/Final_Presentation_Pipeline_Karimi_Lobo.pptx
+++ b/Final_Presentation_Pipeline_Karimi_Lobo.pptx
@@ -1385,7 +1385,7 @@
           </a:p>
           <a:p>
             <a:r>
-              <a:t>everything downstream reads from it. On the right is one real record as it enters</a:t>
+              <a:t>everything downstream reads from it. On the left is one real record as it enters</a:t>
             </a:r>
           </a:p>
           <a:p>
@@ -1501,7 +1501,7 @@
           <a:lstStyle/>
           <a:p>
             <a:r>
-              <a:t>[44s  |  AATISH  |  ~117 words @ 160 wpm]</a:t>
+              <a:t>[44s  |  AATISH  |  ~123 words @ 168 wpm]</a:t>
             </a:r>
           </a:p>
           <a:p>
@@ -1512,58 +1512,69 @@
           <a:p/>
           <a:p>
             <a:r>
-              <a:t>Stage five is Kafka. Four topics, three partitions each, and two of these</a:t>
-            </a:r>
-          </a:p>
-          <a:p>
-            <a:r>
-              <a:t>settings are worth explaining. Retention is twenty-four hours, and that is</a:t>
-            </a:r>
-          </a:p>
-          <a:p>
-            <a:r>
-              <a:t>deliberate, because Kafka is transport for us rather than storage, and the</a:t>
-            </a:r>
-          </a:p>
-          <a:p>
-            <a:r>
-              <a:t>archive Borna just described is what we actually keep. The cleanup policy is</a:t>
-            </a:r>
-          </a:p>
-          <a:p>
-            <a:r>
-              <a:t>delete and never compact, because compaction keeps only the newest message per</a:t>
-            </a:r>
-          </a:p>
-          <a:p>
-            <a:r>
-              <a:t>key and discards the rest, but our data is the history. We detect arrivals by watching a vehicle change state across consecutive</a:t>
-            </a:r>
-          </a:p>
-          <a:p>
-            <a:r>
-              <a:t>observations, so compaction would throw away precisely the thing we read. And the</a:t>
-            </a:r>
-          </a:p>
-          <a:p>
-            <a:r>
-              <a:t>message key puts every observation of one trip into one partition, in order,</a:t>
-            </a:r>
-          </a:p>
-          <a:p>
-            <a:r>
-              <a:t>which turns out to be the whole game.</a:t>
+              <a:t>Stage five is Kafka, and we run four topics. Two of them carry the raw feeds,</a:t>
+            </a:r>
+          </a:p>
+          <a:p>
+            <a:r>
+              <a:t>predictions and vehicle positions. A third is a dead letter topic for records</a:t>
+            </a:r>
+          </a:p>
+          <a:p>
+            <a:r>
+              <a:t>that fail validation, so one malformed row degrades the run rather than stopping</a:t>
+            </a:r>
+          </a:p>
+          <a:p>
+            <a:r>
+              <a:t>it. And the fourth carries the arrivals we derive, so anything downstream can</a:t>
+            </a:r>
+          </a:p>
+          <a:p>
+            <a:r>
+              <a:t>consume them without touching our code.</a:t>
             </a:r>
           </a:p>
           <a:p/>
           <a:p>
             <a:r>
+              <a:t>The three data topics get three partitions each, while the dead letter gets one,</a:t>
+            </a:r>
+          </a:p>
+          <a:p>
+            <a:r>
+              <a:t>because ordering between unrelated broken records is meaningless. We chose three</a:t>
+            </a:r>
+          </a:p>
+          <a:p>
+            <a:r>
+              <a:t>deliberately rather than accepting a default, because partition count is</a:t>
+            </a:r>
+          </a:p>
+          <a:p>
+            <a:r>
+              <a:t>effectively permanent: Kafka routes messages by hashing the key against it, so</a:t>
+            </a:r>
+          </a:p>
+          <a:p>
+            <a:r>
+              <a:t>adding a partition later re-routes keys and breaks per-trip ordering</a:t>
+            </a:r>
+          </a:p>
+          <a:p>
+            <a:r>
+              <a:t>retroactively, for data already written.</a:t>
+            </a:r>
+          </a:p>
+          <a:p/>
+          <a:p>
+            <a:r>
               <a:t>--------------------------------------------------------------</a:t>
             </a:r>
           </a:p>
           <a:p>
             <a:r>
-              <a:t>DELIVERY: Ending on the key sets up the next slide directly.</a:t>
+              <a:t>DELIVERY: Name what each topic is FOR. The partition point is the design choice being scored.</a:t>
             </a:r>
           </a:p>
         </p:txBody>
@@ -1633,7 +1644,7 @@
           <a:lstStyle/>
           <a:p>
             <a:r>
-              <a:t>[50s  |  AATISH  |  ~133 words @ 160 wpm]</a:t>
+              <a:t>[50s  |  AATISH  |  ~125 words @ 150 wpm]</a:t>
             </a:r>
           </a:p>
           <a:p>
@@ -1649,47 +1660,47 @@
           </a:p>
           <a:p>
             <a:r>
-              <a:t>Powell-Mason cable car, and across four consecutive polls you can watch it</a:t>
-            </a:r>
-          </a:p>
-          <a:p>
-            <a:r>
-              <a:t>approach stop four, then report STOPPED_AT at stop four, and then move on to stop</a:t>
-            </a:r>
-          </a:p>
-          <a:p>
-            <a:r>
-              <a:t>six. That transition is the arrival, and that sentence exists nowhere in the</a:t>
-            </a:r>
-          </a:p>
-          <a:p>
-            <a:r>
-              <a:t>source data. We derived it. The subtlety is that it is the first stopped</a:t>
-            </a:r>
-          </a:p>
-          <a:p>
-            <a:r>
-              <a:t>sighting, not the last, because a parked vehicle keeps reporting STOPPED_AT on</a:t>
-            </a:r>
-          </a:p>
-          <a:p>
-            <a:r>
-              <a:t>every poll while it waits. So if you took the last one you would be measuring</a:t>
-            </a:r>
-          </a:p>
-          <a:p>
-            <a:r>
-              <a:t>departure rather than arrival, and nothing would ever tell you that you had it</a:t>
-            </a:r>
-          </a:p>
-          <a:p>
-            <a:r>
-              <a:t>wrong. Which means the resolver has to remember what it saw before, and that is</a:t>
-            </a:r>
-          </a:p>
-          <a:p>
-            <a:r>
-              <a:t>exactly why the ordering guarantee matters.</a:t>
+              <a:t>Powell-Mason cable car, across four consecutive polls. The status field comes</a:t>
+            </a:r>
+          </a:p>
+          <a:p>
+            <a:r>
+              <a:t>straight from the feed, so when Muni's own equipment reports STOPPED_AT at stop</a:t>
+            </a:r>
+          </a:p>
+          <a:p>
+            <a:r>
+              <a:t>four, we are reading that rather than inferring it. What we derive is the</a:t>
+            </a:r>
+          </a:p>
+          <a:p>
+            <a:r>
+              <a:t>arrival: the moment that status first appears for that stop. We take the first</a:t>
+            </a:r>
+          </a:p>
+          <a:p>
+            <a:r>
+              <a:t>sighting rather than the last, because a parked vehicle keeps reporting stopped</a:t>
+            </a:r>
+          </a:p>
+          <a:p>
+            <a:r>
+              <a:t>on every poll, so the last one would measure departure. That derived sentence,</a:t>
+            </a:r>
+          </a:p>
+          <a:p>
+            <a:r>
+              <a:t>this trip arrived at stop four at 14:54:31, exists nowhere in the source data,</a:t>
+            </a:r>
+          </a:p>
+          <a:p>
+            <a:r>
+              <a:t>and producing it requires the resolver to hold per-trip state, which is exactly</a:t>
+            </a:r>
+          </a:p>
+          <a:p>
+            <a:r>
+              <a:t>why the ordering guarantee matters.</a:t>
             </a:r>
           </a:p>
           <a:p/>
@@ -1700,7 +1711,7 @@
           </a:p>
           <a:p>
             <a:r>
-              <a:t>DELIVERY: The rubric asks for one concrete example. Trace the four lines with your finger.</a:t>
+              <a:t>DELIVERY: The read-vs-derived distinction is the point. First-vs-last is now one sentence.</a:t>
             </a:r>
           </a:p>
         </p:txBody>
@@ -18417,22 +18428,13 @@
               </a:spcAft>
             </a:pPr>
             <a:r>
-              <a:rPr sz="1400" b="0">
+              <a:rPr sz="1400" b="1">
                 <a:solidFill>
                   <a:srgbClr val="1A1F2B"/>
                 </a:solidFill>
                 <a:latin typeface="Calibri"/>
               </a:rPr>
-              <a:t>That sentence exists </a:t>
-            </a:r>
-            <a:r>
-              <a:rPr sz="1400" b="1">
-                <a:solidFill>
-                  <a:srgbClr val="1A1F2B"/>
-                </a:solidFill>
-                <a:latin typeface="Calibri"/>
-              </a:rPr>
-              <a:t>nowhere</a:t>
+              <a:t>READ from the feed:</a:t>
             </a:r>
           </a:p>
           <a:p>
@@ -18451,7 +18453,7 @@
                 </a:solidFill>
                 <a:latin typeface="Calibri"/>
               </a:rPr>
-              <a:t>in the source data.</a:t>
+              <a:t>`current_status` is a published</a:t>
             </a:r>
           </a:p>
           <a:p>
@@ -18463,6 +18465,15 @@
                 <a:spcPts val="600"/>
               </a:spcAft>
             </a:pPr>
+            <a:r>
+              <a:rPr sz="1400" b="0">
+                <a:solidFill>
+                  <a:srgbClr val="1A1F2B"/>
+                </a:solidFill>
+                <a:latin typeface="Calibri"/>
+              </a:rPr>
+              <a:t>GTFS-RT field — we don't infer it.</a:t>
+            </a:r>
           </a:p>
           <a:p>
             <a:pPr algn="l">
@@ -18473,33 +18484,6 @@
                 <a:spcPts val="600"/>
               </a:spcAft>
             </a:pPr>
-            <a:r>
-              <a:rPr sz="1400" b="0">
-                <a:solidFill>
-                  <a:srgbClr val="1A1F2B"/>
-                </a:solidFill>
-                <a:latin typeface="Calibri"/>
-              </a:rPr>
-              <a:t>It is the </a:t>
-            </a:r>
-            <a:r>
-              <a:rPr sz="1400" b="1">
-                <a:solidFill>
-                  <a:srgbClr val="1A1F2B"/>
-                </a:solidFill>
-                <a:latin typeface="Calibri"/>
-              </a:rPr>
-              <a:t>first</a:t>
-            </a:r>
-            <a:r>
-              <a:rPr sz="1400" b="0">
-                <a:solidFill>
-                  <a:srgbClr val="1A1F2B"/>
-                </a:solidFill>
-                <a:latin typeface="Calibri"/>
-              </a:rPr>
-              <a:t> stopped sighting —</a:t>
-            </a:r>
           </a:p>
           <a:p>
             <a:pPr algn="l">
@@ -18511,13 +18495,13 @@
               </a:spcAft>
             </a:pPr>
             <a:r>
-              <a:rPr sz="1400" b="0">
+              <a:rPr sz="1400" b="1">
                 <a:solidFill>
                   <a:srgbClr val="1A1F2B"/>
                 </a:solidFill>
                 <a:latin typeface="Calibri"/>
               </a:rPr>
-              <a:t>a parked vehicle reports STOPPED_AT</a:t>
+              <a:t>DERIVED by us:</a:t>
             </a:r>
           </a:p>
           <a:p>
@@ -18536,7 +18520,7 @@
                 </a:solidFill>
                 <a:latin typeface="Calibri"/>
               </a:rPr>
-              <a:t>on every poll, so the last one</a:t>
+              <a:t>the arrival — the moment that</a:t>
             </a:r>
           </a:p>
           <a:p>
@@ -18555,25 +18539,7 @@
                 </a:solidFill>
                 <a:latin typeface="Calibri"/>
               </a:rPr>
-              <a:t>would measure </a:t>
-            </a:r>
-            <a:r>
-              <a:rPr sz="1400" b="1">
-                <a:solidFill>
-                  <a:srgbClr val="1A1F2B"/>
-                </a:solidFill>
-                <a:latin typeface="Calibri"/>
-              </a:rPr>
-              <a:t>departure</a:t>
-            </a:r>
-            <a:r>
-              <a:rPr sz="1400" b="0">
-                <a:solidFill>
-                  <a:srgbClr val="1A1F2B"/>
-                </a:solidFill>
-                <a:latin typeface="Calibri"/>
-              </a:rPr>
-              <a:t>.</a:t>
+              <a:t>status *first* appears for a stop.</a:t>
             </a:r>
           </a:p>
           <a:p>
@@ -18602,7 +18568,7 @@
                 </a:solidFill>
                 <a:latin typeface="Calibri"/>
               </a:rPr>
-              <a:t>So the resolver holds per-trip state —</a:t>
+              <a:t>First, not last: a parked vehicle</a:t>
             </a:r>
           </a:p>
           <a:p>
@@ -18621,7 +18587,26 @@
                 </a:solidFill>
                 <a:latin typeface="Calibri"/>
               </a:rPr>
-              <a:t>which is why </a:t>
+              <a:t>reports it every poll, so the last</a:t>
+            </a:r>
+          </a:p>
+          <a:p>
+            <a:pPr algn="l">
+              <a:lnSpc>
+                <a:spcPct val="132000"/>
+              </a:lnSpc>
+              <a:spcAft>
+                <a:spcPts val="600"/>
+              </a:spcAft>
+            </a:pPr>
+            <a:r>
+              <a:rPr sz="1400" b="0">
+                <a:solidFill>
+                  <a:srgbClr val="1A1F2B"/>
+                </a:solidFill>
+                <a:latin typeface="Calibri"/>
+              </a:rPr>
+              <a:t>would be </a:t>
             </a:r>
             <a:r>
               <a:rPr sz="1400" b="1">
@@ -18630,7 +18615,7 @@
                 </a:solidFill>
                 <a:latin typeface="Calibri"/>
               </a:rPr>
-              <a:t>ordering</a:t>
+              <a:t>departure</a:t>
             </a:r>
             <a:r>
               <a:rPr sz="1400" b="0">
@@ -18639,7 +18624,7 @@
                 </a:solidFill>
                 <a:latin typeface="Calibri"/>
               </a:rPr>
-              <a:t> matters.</a:t>
+              <a:t>.</a:t>
             </a:r>
           </a:p>
         </p:txBody>

</xml_diff>

<commit_message>
Trim slide 6 to reading pace
</commit_message>
<xml_diff>
--- a/Final_Presentation_Pipeline_Karimi_Lobo.pptx
+++ b/Final_Presentation_Pipeline_Karimi_Lobo.pptx
@@ -1501,7 +1501,7 @@
           <a:lstStyle/>
           <a:p>
             <a:r>
-              <a:t>[44s  |  AATISH  |  ~123 words @ 168 wpm]</a:t>
+              <a:t>[44s  |  AATISH  |  ~121 words @ 165 wpm]</a:t>
             </a:r>
           </a:p>
           <a:p>
@@ -1527,12 +1527,12 @@
           </a:p>
           <a:p>
             <a:r>
-              <a:t>it. And the fourth carries the arrivals we derive, so anything downstream can</a:t>
-            </a:r>
-          </a:p>
-          <a:p>
-            <a:r>
-              <a:t>consume them without touching our code.</a:t>
+              <a:t>it. The fourth carries the arrivals we derive, so anything downstream can consume</a:t>
+            </a:r>
+          </a:p>
+          <a:p>
+            <a:r>
+              <a:t>them without touching our code.</a:t>
             </a:r>
           </a:p>
           <a:p/>
@@ -1553,17 +1553,17 @@
           </a:p>
           <a:p>
             <a:r>
-              <a:t>effectively permanent: Kafka routes messages by hashing the key against it, so</a:t>
-            </a:r>
-          </a:p>
-          <a:p>
-            <a:r>
-              <a:t>adding a partition later re-routes keys and breaks per-trip ordering</a:t>
-            </a:r>
-          </a:p>
-          <a:p>
-            <a:r>
-              <a:t>retroactively, for data already written.</a:t>
+              <a:t>effectively permanent: Kafka routes by hashing the key against it, so adding a</a:t>
+            </a:r>
+          </a:p>
+          <a:p>
+            <a:r>
+              <a:t>partition later re-routes keys and breaks per-trip ordering retroactively, for</a:t>
+            </a:r>
+          </a:p>
+          <a:p>
+            <a:r>
+              <a:t>data already written.</a:t>
             </a:r>
           </a:p>
           <a:p/>

</xml_diff>